<commit_message>
Polish B6 walk deck and extend A3 peer column for Guru Thu.
Move B6 rehearse script out of pptx with on-slide Lead cues, tighten engineering language, and add Hongal ECMP/LAG/Counters plus peer DRIs on A3 slide 2.

Co-authored-by: Cursor <cursoragent@cursor.com>
</commit_message>
<xml_diff>
--- a/dt100/manager-arch-vision-b6.pptx
+++ b/dt100/manager-arch-vision-b6.pptx
@@ -6344,6 +6344,18 @@
           </a:p>
           <a:p>
             <a:pPr/>
+            <a:r>
+              <a:rPr sz="1300">
+                <a:solidFill>
+                  <a:srgbClr val="333333"/>
+                </a:solidFill>
+                <a:latin typeface="Arial"/>
+              </a:rPr>
+              <a:t>Explicitly out of Thu — weekly sync, not merged plans.</a:t>
+            </a:r>
+          </a:p>
+          <a:p>
+            <a:pPr/>
           </a:p>
           <a:p>
             <a:pPr/>
@@ -6354,7 +6366,7 @@
                 </a:solidFill>
                 <a:latin typeface="Arial"/>
               </a:rPr>
-              <a:t>Rupa SDK/SAI/datapath layout — related, different plan; weekly sync, not on Thu</a:t>
+              <a:t>Rupa SDK/SAI/datapath layout — related, different plan; weekly sync</a:t>
             </a:r>
           </a:p>
           <a:p>
@@ -6366,7 +6378,7 @@
                 </a:solidFill>
                 <a:latin typeface="Arial"/>
               </a:rPr>
-              <a:t>OCP ESUN: coordinate with Rupa before vendor calls; company position through Sponsor</a:t>
+              <a:t>OCP ESUN: coordinate with Rupa before vendor calls; company position through Gururaj</a:t>
             </a:r>
           </a:p>
           <a:p>
@@ -6825,6 +6837,18 @@
           </a:p>
           <a:p>
             <a:pPr/>
+            <a:r>
+              <a:rPr sz="1300">
+                <a:solidFill>
+                  <a:srgbClr val="333333"/>
+                </a:solidFill>
+                <a:latin typeface="Arial"/>
+              </a:rPr>
+              <a:t>Offer only if asked — who must be in the room.</a:t>
+            </a:r>
+          </a:p>
+          <a:p>
+            <a:pPr/>
           </a:p>
           <a:p>
             <a:pPr/>
@@ -6859,7 +6883,7 @@
                 </a:solidFill>
                 <a:latin typeface="Arial"/>
               </a:rPr>
-              <a:t>Cadence: Shafi, Tippanna, Rupa, Prasun — only if Sponsor redirects execution to me</a:t>
+              <a:t>Cadence: Shafi, Tippanna, Rupa, Prasun — if Gururaj redirects drive to me</a:t>
             </a:r>
           </a:p>
           <a:p>
@@ -6871,7 +6895,7 @@
                 </a:solidFill>
                 <a:latin typeface="Arial"/>
               </a:rPr>
-              <a:t>Who must be in the room — offer here if you ask (not on A3)</a:t>
+              <a:t>Room list — offer here if you ask (not on A3)</a:t>
             </a:r>
           </a:p>
         </p:txBody>
@@ -7318,6 +7342,18 @@
           </a:p>
           <a:p>
             <a:pPr/>
+            <a:r>
+              <a:rPr sz="1300">
+                <a:solidFill>
+                  <a:srgbClr val="333333"/>
+                </a:solidFill>
+                <a:latin typeface="Arial"/>
+              </a:rPr>
+              <a:t>Boundaries — keeps Thu walkable.</a:t>
+            </a:r>
+          </a:p>
+          <a:p>
+            <a:pPr/>
           </a:p>
           <a:p>
             <a:pPr/>
@@ -7799,6 +7835,18 @@
           </a:p>
           <a:p>
             <a:pPr/>
+            <a:r>
+              <a:rPr sz="1300">
+                <a:solidFill>
+                  <a:srgbClr val="333333"/>
+                </a:solidFill>
+                <a:latin typeface="Arial"/>
+              </a:rPr>
+              <a:t>Transition — A3 framed situation + task; this walk defines how.</a:t>
+            </a:r>
+          </a:p>
+          <a:p>
+            <a:pPr/>
           </a:p>
           <a:p>
             <a:pPr/>
@@ -7809,7 +7857,7 @@
                 </a:solidFill>
                 <a:latin typeface="Arial"/>
               </a:rPr>
-              <a:t>Assumption: situation and task on A3 slides 1–2 are aligned.</a:t>
+              <a:t>Assumption: A3 slides 1–2 aligned on program bar + QoS RM wedge.</a:t>
             </a:r>
           </a:p>
           <a:p>
@@ -7821,7 +7869,7 @@
                 </a:solidFill>
                 <a:latin typeface="Arial"/>
               </a:rPr>
-              <a:t>This walk: show vision and draft plan — validation machine, owners, QoS wedge on pipeline; co-evolve execution live (I am the deliverable, not a PDF).</a:t>
+              <a:t>Show validation machine, owners, QoS on logical pipeline — co-evolve plan live.</a:t>
             </a:r>
           </a:p>
           <a:p>
@@ -7833,7 +7881,7 @@
                 </a:solidFill>
                 <a:latin typeface="Arial"/>
               </a:rPr>
-              <a:t>After walk: A3 slides 3–4 — mandate and sponsor trust (not repeated here).</a:t>
+              <a:t>Close on A3 slides 3–4 (sprint scope + alignment) — not repeated here.</a:t>
             </a:r>
           </a:p>
         </p:txBody>
@@ -8280,6 +8328,18 @@
           </a:p>
           <a:p>
             <a:pPr/>
+            <a:r>
+              <a:rPr sz="1300">
+                <a:solidFill>
+                  <a:srgbClr val="333333"/>
+                </a:solidFill>
+                <a:latin typeface="Arial"/>
+              </a:rPr>
+              <a:t>Thin walk today; depth only if Gururaj redirects.</a:t>
+            </a:r>
+          </a:p>
+          <a:p>
+            <a:pPr/>
           </a:p>
           <a:p>
             <a:pPr/>
@@ -8302,7 +8362,7 @@
                 </a:solidFill>
                 <a:latin typeface="Arial"/>
               </a:rPr>
-              <a:t>Next: only if Sponsor directs — expand B6, swimlanes, integrated validation plans (depth and format your steer).</a:t>
+              <a:t>Next: expand swimlanes / integrated validation plans — format and depth per your steer.</a:t>
             </a:r>
           </a:p>
           <a:p>
@@ -8761,6 +8821,18 @@
           </a:p>
           <a:p>
             <a:pPr/>
+            <a:r>
+              <a:rPr sz="1300">
+                <a:solidFill>
+                  <a:srgbClr val="333333"/>
+                </a:solidFill>
+                <a:latin typeface="Arial"/>
+              </a:rPr>
+              <a:t>Gates are v0 for group review — not unilateral.</a:t>
+            </a:r>
+          </a:p>
+          <a:p>
+            <a:pPr/>
           </a:p>
           <a:p>
             <a:pPr/>
@@ -8783,7 +8855,7 @@
                 </a:solidFill>
                 <a:latin typeface="Arial"/>
               </a:rPr>
-              <a:t>Arch validation (AV) ↔ datapath arch</a:t>
+              <a:t>Architecture validation (AV) ↔ datapath arch</a:t>
             </a:r>
           </a:p>
           <a:p>
@@ -8831,7 +8903,7 @@
                 </a:solidFill>
                 <a:latin typeface="Arial"/>
               </a:rPr>
-              <a:t>I socialize v0 of done per gate for group review — not unilateral mandate.</a:t>
+              <a:t>I socialize v0 “done” per gate; peers own slice proof.</a:t>
             </a:r>
           </a:p>
         </p:txBody>
@@ -9278,6 +9350,18 @@
           </a:p>
           <a:p>
             <a:pPr/>
+            <a:r>
+              <a:rPr sz="1300">
+                <a:solidFill>
+                  <a:srgbClr val="333333"/>
+                </a:solidFill>
+                <a:latin typeface="Arial"/>
+              </a:rPr>
+              <a:t>Name DRIs once; point at pipeline slide next.</a:t>
+            </a:r>
+          </a:p>
+          <a:p>
+            <a:pPr/>
           </a:p>
           <a:p>
             <a:pPr/>
@@ -9288,7 +9372,7 @@
                 </a:solidFill>
                 <a:latin typeface="Arial"/>
               </a:rPr>
-              <a:t>Sponsor (Gururaj): exec alignment — external narrative</a:t>
+              <a:t>Gururaj: scope · company / OCP external</a:t>
             </a:r>
           </a:p>
           <a:p>
@@ -9312,7 +9396,7 @@
                 </a:solidFill>
                 <a:latin typeface="Arial"/>
               </a:rPr>
-              <a:t>L2/L3 / ACL: Shafi Mohammad · ECMP / AV: Tippanna Hongal</a:t>
+              <a:t>L2/L3 / ACL: Shafi Mohammad · ECMP / LAG / Counters · AV: Tippanna Hongal</a:t>
             </a:r>
           </a:p>
           <a:p>
@@ -9783,6 +9867,18 @@
           </a:p>
           <a:p>
             <a:pPr/>
+            <a:r>
+              <a:rPr sz="1300">
+                <a:solidFill>
+                  <a:srgbClr val="333333"/>
+                </a:solidFill>
+                <a:latin typeface="Arial"/>
+              </a:rPr>
+              <a:t>DSCP/TOS → TC → queues → schedulers; carve at CSB.</a:t>
+            </a:r>
+          </a:p>
+          <a:p>
+            <a:pPr/>
           </a:p>
           <a:p>
             <a:pPr/>
@@ -9841,7 +9937,7 @@
                 </a:solidFill>
                 <a:latin typeface="Arial"/>
               </a:rPr>
-              <a:t>HWv1 now: no MPLS EXP, no IPv6 priority mapping yet · HWv2: EXP + IPv6 pri</a:t>
+              <a:t>HWv1: no MPLS EXP, no IPv6 priority mapping · HWv2: EXP + IPv6 pri</a:t>
             </a:r>
           </a:p>
         </p:txBody>
@@ -10742,6 +10838,18 @@
           </a:p>
           <a:p>
             <a:pPr/>
+            <a:r>
+              <a:rPr sz="1300">
+                <a:solidFill>
+                  <a:srgbClr val="333333"/>
+                </a:solidFill>
+                <a:latin typeface="Arial"/>
+              </a:rPr>
+              <a:t>Only if Gururaj asks — each block needs AV + SW proof before silicon.</a:t>
+            </a:r>
+          </a:p>
+          <a:p>
+            <a:pPr/>
           </a:p>
           <a:p>
             <a:pPr/>
@@ -10752,7 +10860,7 @@
                 </a:solidFill>
                 <a:latin typeface="Arial"/>
               </a:rPr>
-              <a:t>Ingress / Parser — align parse correctness with Rupa before OCP/BCM calls</a:t>
+              <a:t>Ingress / Parser — parse correctness with Rupa before OCP/BCM calls</a:t>
             </a:r>
           </a:p>
           <a:p>
@@ -10764,7 +10872,7 @@
                 </a:solidFill>
                 <a:latin typeface="Arial"/>
               </a:rPr>
-              <a:t>L2 — Shafi · Forward: ECMP (Tippanna), QoSMAP (me) · Egress Queue/carve (me)</a:t>
+              <a:t>L2 — Shafi · Forward: ECMP / LAG / Counters (Tippanna), QoSMAP (me) · Egress Queue/carve (me)</a:t>
             </a:r>
           </a:p>
           <a:p>
@@ -10776,7 +10884,7 @@
                 </a:solidFill>
                 <a:latin typeface="Arial"/>
               </a:rPr>
-              <a:t>Each block: AV done + SW proof (C-model → emulation) before silicon — I draft cross-block gates</a:t>
+              <a:t>I draft cross-block gates; block DRIs own slice proof (C-model → emulation)</a:t>
             </a:r>
           </a:p>
         </p:txBody>

</xml_diff>